<commit_message>
Update README, results and docs with latest training run
</commit_message>
<xml_diff>
--- a/doc/Review_Aspect_Analyzer.pptx
+++ b/doc/Review_Aspect_Analyzer.pptx
@@ -4251,7 +4251,7 @@
                   <a:schemeClr val="tx1"/>
                 </a:solidFill>
               </a:rPr>
-              <a:t>80.27%</a:t>
+              <a:t>77.26%</a:t>
             </a:r>
             <a:endParaRPr lang="en-US" sz="1300" dirty="0"/>
           </a:p>
@@ -4373,7 +4373,7 @@
                   <a:schemeClr val="tx1"/>
                 </a:solidFill>
               </a:rPr>
-              <a:t>0.7408</a:t>
+              <a:t>0.7089</a:t>
             </a:r>
             <a:endParaRPr lang="en-US" sz="1300" dirty="0"/>
           </a:p>
@@ -5388,7 +5388,7 @@
                   <a:schemeClr val="bg1"/>
                 </a:solidFill>
               </a:rPr>
-              <a:t>Conclusion: a fine-tuned BERT model reached 80.27% test accuracy and gives a sentiment for each aspect of a review, which is more useful than one overall label.</a:t>
+              <a:t>Conclusion: a fine-tuned BERT model reached 77.26% test accuracy and gives a sentiment for each aspect of a review, which is more useful than one overall label.</a:t>
             </a:r>
             <a:endParaRPr lang="en-US" sz="1400" dirty="0"/>
           </a:p>

</xml_diff>